<commit_message>
fix oom by reduce buffer size.
</commit_message>
<xml_diff>
--- a/images/arch.pptx
+++ b/images/arch.pptx
@@ -288,7 +288,7 @@
           <a:p>
             <a:fld id="{9E50BDAC-40CF-4CAB-92B6-8882156A02C4}" type="datetimeFigureOut">
               <a:rPr lang="zh-CN" altLang="en-US" smtClean="0"/>
-              <a:t>2026/5/14</a:t>
+              <a:t>2026/5/20</a:t>
             </a:fld>
             <a:endParaRPr lang="zh-CN" altLang="en-US"/>
           </a:p>
@@ -458,7 +458,7 @@
           <a:p>
             <a:fld id="{9E50BDAC-40CF-4CAB-92B6-8882156A02C4}" type="datetimeFigureOut">
               <a:rPr lang="zh-CN" altLang="en-US" smtClean="0"/>
-              <a:t>2026/5/14</a:t>
+              <a:t>2026/5/20</a:t>
             </a:fld>
             <a:endParaRPr lang="zh-CN" altLang="en-US"/>
           </a:p>
@@ -638,7 +638,7 @@
           <a:p>
             <a:fld id="{9E50BDAC-40CF-4CAB-92B6-8882156A02C4}" type="datetimeFigureOut">
               <a:rPr lang="zh-CN" altLang="en-US" smtClean="0"/>
-              <a:t>2026/5/14</a:t>
+              <a:t>2026/5/20</a:t>
             </a:fld>
             <a:endParaRPr lang="zh-CN" altLang="en-US"/>
           </a:p>
@@ -808,7 +808,7 @@
           <a:p>
             <a:fld id="{9E50BDAC-40CF-4CAB-92B6-8882156A02C4}" type="datetimeFigureOut">
               <a:rPr lang="zh-CN" altLang="en-US" smtClean="0"/>
-              <a:t>2026/5/14</a:t>
+              <a:t>2026/5/20</a:t>
             </a:fld>
             <a:endParaRPr lang="zh-CN" altLang="en-US"/>
           </a:p>
@@ -1054,7 +1054,7 @@
           <a:p>
             <a:fld id="{9E50BDAC-40CF-4CAB-92B6-8882156A02C4}" type="datetimeFigureOut">
               <a:rPr lang="zh-CN" altLang="en-US" smtClean="0"/>
-              <a:t>2026/5/14</a:t>
+              <a:t>2026/5/20</a:t>
             </a:fld>
             <a:endParaRPr lang="zh-CN" altLang="en-US"/>
           </a:p>
@@ -1342,7 +1342,7 @@
           <a:p>
             <a:fld id="{9E50BDAC-40CF-4CAB-92B6-8882156A02C4}" type="datetimeFigureOut">
               <a:rPr lang="zh-CN" altLang="en-US" smtClean="0"/>
-              <a:t>2026/5/14</a:t>
+              <a:t>2026/5/20</a:t>
             </a:fld>
             <a:endParaRPr lang="zh-CN" altLang="en-US"/>
           </a:p>
@@ -1764,7 +1764,7 @@
           <a:p>
             <a:fld id="{9E50BDAC-40CF-4CAB-92B6-8882156A02C4}" type="datetimeFigureOut">
               <a:rPr lang="zh-CN" altLang="en-US" smtClean="0"/>
-              <a:t>2026/5/14</a:t>
+              <a:t>2026/5/20</a:t>
             </a:fld>
             <a:endParaRPr lang="zh-CN" altLang="en-US"/>
           </a:p>
@@ -1882,7 +1882,7 @@
           <a:p>
             <a:fld id="{9E50BDAC-40CF-4CAB-92B6-8882156A02C4}" type="datetimeFigureOut">
               <a:rPr lang="zh-CN" altLang="en-US" smtClean="0"/>
-              <a:t>2026/5/14</a:t>
+              <a:t>2026/5/20</a:t>
             </a:fld>
             <a:endParaRPr lang="zh-CN" altLang="en-US"/>
           </a:p>
@@ -1977,7 +1977,7 @@
           <a:p>
             <a:fld id="{9E50BDAC-40CF-4CAB-92B6-8882156A02C4}" type="datetimeFigureOut">
               <a:rPr lang="zh-CN" altLang="en-US" smtClean="0"/>
-              <a:t>2026/5/14</a:t>
+              <a:t>2026/5/20</a:t>
             </a:fld>
             <a:endParaRPr lang="zh-CN" altLang="en-US"/>
           </a:p>
@@ -2254,7 +2254,7 @@
           <a:p>
             <a:fld id="{9E50BDAC-40CF-4CAB-92B6-8882156A02C4}" type="datetimeFigureOut">
               <a:rPr lang="zh-CN" altLang="en-US" smtClean="0"/>
-              <a:t>2026/5/14</a:t>
+              <a:t>2026/5/20</a:t>
             </a:fld>
             <a:endParaRPr lang="zh-CN" altLang="en-US"/>
           </a:p>
@@ -2507,7 +2507,7 @@
           <a:p>
             <a:fld id="{9E50BDAC-40CF-4CAB-92B6-8882156A02C4}" type="datetimeFigureOut">
               <a:rPr lang="zh-CN" altLang="en-US" smtClean="0"/>
-              <a:t>2026/5/14</a:t>
+              <a:t>2026/5/20</a:t>
             </a:fld>
             <a:endParaRPr lang="zh-CN" altLang="en-US"/>
           </a:p>
@@ -2720,7 +2720,7 @@
           <a:p>
             <a:fld id="{9E50BDAC-40CF-4CAB-92B6-8882156A02C4}" type="datetimeFigureOut">
               <a:rPr lang="zh-CN" altLang="en-US" smtClean="0"/>
-              <a:t>2026/5/14</a:t>
+              <a:t>2026/5/20</a:t>
             </a:fld>
             <a:endParaRPr lang="zh-CN" altLang="en-US"/>
           </a:p>
@@ -5806,9 +5806,9 @@
       </p:sp>
       <p:pic>
         <p:nvPicPr>
-          <p:cNvPr id="2" name="图片 1"/>
+          <p:cNvPr id="1026" name="Picture 2"/>
           <p:cNvPicPr>
-            <a:picLocks noChangeAspect="1"/>
+            <a:picLocks noChangeAspect="1" noChangeArrowheads="1"/>
           </p:cNvPicPr>
           <p:nvPr/>
         </p:nvPicPr>
@@ -5820,18 +5820,52 @@
               </a:ext>
             </a:extLst>
           </a:blip>
+          <a:srcRect/>
           <a:stretch>
             <a:fillRect/>
           </a:stretch>
         </p:blipFill>
-        <p:spPr>
+        <p:spPr bwMode="auto">
           <a:xfrm>
-            <a:off x="936179" y="1844824"/>
-            <a:ext cx="2285739" cy="1267024"/>
+            <a:off x="936179" y="1844823"/>
+            <a:ext cx="2315828" cy="1281813"/>
           </a:xfrm>
           <a:prstGeom prst="rect">
             <a:avLst/>
           </a:prstGeom>
+          <a:noFill/>
+          <a:ln>
+            <a:noFill/>
+          </a:ln>
+          <a:effectLst/>
+          <a:extLst>
+            <a:ext uri="{909E8E84-426E-40DD-AFC4-6F175D3DCCD1}">
+              <a14:hiddenFill xmlns:a14="http://schemas.microsoft.com/office/drawing/2010/main">
+                <a:solidFill>
+                  <a:schemeClr val="accent1"/>
+                </a:solidFill>
+              </a14:hiddenFill>
+            </a:ext>
+            <a:ext uri="{91240B29-F687-4F45-9708-019B960494DF}">
+              <a14:hiddenLine xmlns:a14="http://schemas.microsoft.com/office/drawing/2010/main" w="9525">
+                <a:solidFill>
+                  <a:schemeClr val="tx1"/>
+                </a:solidFill>
+                <a:miter lim="800000"/>
+                <a:headEnd/>
+                <a:tailEnd/>
+              </a14:hiddenLine>
+            </a:ext>
+            <a:ext uri="{AF507438-7753-43E0-B8FC-AC1667EBCBE1}">
+              <a14:hiddenEffects xmlns:a14="http://schemas.microsoft.com/office/drawing/2010/main">
+                <a:effectLst>
+                  <a:outerShdw dist="35921" dir="2700000" algn="ctr" rotWithShape="0">
+                    <a:schemeClr val="bg2"/>
+                  </a:outerShdw>
+                </a:effectLst>
+              </a14:hiddenEffects>
+            </a:ext>
+          </a:extLst>
         </p:spPr>
       </p:pic>
     </p:spTree>

</xml_diff>